<commit_message>
Tighten the deck so each slide answers its question.
</commit_message>
<xml_diff>
--- a/Template/Out/Multimodal Studio - AI Builder Cup.pptx
+++ b/Template/Out/Multimodal Studio - AI Builder Cup.pptx
@@ -7085,7 +7085,7 @@
                 <a:cs typeface="Google Sans Flex"/>
                 <a:sym typeface="Google Sans Flex"/>
               </a:rPr>
-              <a:t>Team leader: Anil Kumar  ·  anil8860556664@gmail.com</a:t>
+              <a:t>Team leader name: M Sai Teja</a:t>
             </a:r>
             <a:endParaRPr sz="1800">
               <a:latin typeface="Google Sans Flex"/>
@@ -7113,7 +7113,7 @@
                 <a:cs typeface="Google Sans Flex"/>
                 <a:sym typeface="Google Sans Flex"/>
               </a:rPr>
-              <a:t>Member: M Sai Teja  ·  macharlasaiteja@gmail.com.  A chapter still becomes slides by hand, then a recording. Students get a flat read-aloud. We wanted a video they would actually replay.</a:t>
+              <a:t>Problem statement: A teacher still rebuilds a chapter as slides, then records it. The voice and the picture do not move together, so students get a page read aloud.</a:t>
             </a:r>
             <a:endParaRPr sz="1800">
               <a:latin typeface="Google Sans Flex"/>
@@ -7412,7 +7412,7 @@
                 <a:cs typeface="Google Sans Flex"/>
                 <a:sym typeface="Google Sans Flex"/>
               </a:rPr>
-              <a:t>No GPU. The only bill is the Gemini API.</a:t>
+              <a:t>No GPU. A normal video on Gemini Flash is a few rupees.</a:t>
             </a:r>
           </a:p>
           <a:p>
@@ -7434,51 +7434,7 @@
                 <a:cs typeface="Google Sans Flex"/>
                 <a:sym typeface="Google Sans Flex"/>
               </a:rPr>
-              <a:t>On Flash, a normal video is a few rupees. Argon costs more, so we turn it on when the source needs it, not for every run.</a:t>
-            </a:r>
-          </a:p>
-          <a:p>
-            <a:pPr algn="l">
-              <a:spcBef>
-                <a:spcPts val="0"/>
-              </a:spcBef>
-              <a:spcAft>
-                <a:spcPts val="800"/>
-              </a:spcAft>
-            </a:pPr>
-            <a:r>
-              <a:rPr sz="1400" b="0" i="0">
-                <a:solidFill>
-                  <a:srgbClr val="1F1F1F"/>
-                </a:solidFill>
-                <a:latin typeface="Google Sans Flex"/>
-                <a:ea typeface="Google Sans Flex"/>
-                <a:cs typeface="Google Sans Flex"/>
-                <a:sym typeface="Google Sans Flex"/>
-              </a:rPr>
-              <a:t>Cloud Run and Firestore should stay inside the free tier for the number of people who will open this during review.</a:t>
-            </a:r>
-          </a:p>
-          <a:p>
-            <a:pPr algn="l">
-              <a:spcBef>
-                <a:spcPts val="0"/>
-              </a:spcBef>
-              <a:spcAft>
-                <a:spcPts val="800"/>
-              </a:spcAft>
-            </a:pPr>
-            <a:r>
-              <a:rPr sz="1400" b="0" i="0">
-                <a:solidFill>
-                  <a:srgbClr val="1F1F1F"/>
-                </a:solidFill>
-                <a:latin typeface="Google Sans Flex"/>
-                <a:ea typeface="Google Sans Flex"/>
-                <a:cs typeface="Google Sans Flex"/>
-                <a:sym typeface="Google Sans Flex"/>
-              </a:rPr>
-              <a:t>We have not switched on a paid hosting plan. The API key is the thing that has to be set.</a:t>
+              <a:t>Cloud Run and Firestore stay in the free tier for review traffic.</a:t>
             </a:r>
           </a:p>
         </p:txBody>
@@ -7717,8 +7673,8 @@
         </p:blipFill>
         <p:spPr>
           <a:xfrm>
-            <a:off x="292608" y="1783080"/>
-            <a:ext cx="2743200" cy="1362456"/>
+            <a:off x="365760" y="1874519"/>
+            <a:ext cx="2651760" cy="1316736"/>
           </a:xfrm>
           <a:prstGeom prst="rect">
             <a:avLst/>
@@ -7733,8 +7689,8 @@
         </p:nvSpPr>
         <p:spPr>
           <a:xfrm>
-            <a:off x="292608" y="3218688"/>
-            <a:ext cx="2743200" cy="1371600"/>
+            <a:off x="365760" y="3273552"/>
+            <a:ext cx="2651760" cy="822960"/>
           </a:xfrm>
           <a:prstGeom prst="rect">
             <a:avLst/>
@@ -7763,7 +7719,7 @@
                 <a:cs typeface="Google Sans Flex"/>
                 <a:sym typeface="Google Sans Flex"/>
               </a:rPr>
-              <a:t>Where a run starts. File on the left, format and voice, then run.</a:t>
+              <a:t>Studio. Drop the file and run.</a:t>
             </a:r>
           </a:p>
         </p:txBody>
@@ -7784,8 +7740,8 @@
         </p:blipFill>
         <p:spPr>
           <a:xfrm>
-            <a:off x="3172968" y="1783080"/>
-            <a:ext cx="2743200" cy="1362456"/>
+            <a:off x="3246120" y="1874519"/>
+            <a:ext cx="2651760" cy="1316736"/>
           </a:xfrm>
           <a:prstGeom prst="rect">
             <a:avLst/>
@@ -7800,8 +7756,8 @@
         </p:nvSpPr>
         <p:spPr>
           <a:xfrm>
-            <a:off x="3172968" y="3218688"/>
-            <a:ext cx="2743200" cy="1371600"/>
+            <a:off x="3246120" y="3273552"/>
+            <a:ext cx="2651760" cy="822960"/>
           </a:xfrm>
           <a:prstGeom prst="rect">
             <a:avLst/>
@@ -7830,7 +7786,7 @@
                 <a:cs typeface="Google Sans Flex"/>
                 <a:sym typeface="Google Sans Flex"/>
               </a:rPr>
-              <a:t>Kore is the voice in the demo. You can hear it before you commit.</a:t>
+              <a:t>Pick a voice before you run.</a:t>
             </a:r>
           </a:p>
         </p:txBody>
@@ -7851,8 +7807,8 @@
         </p:blipFill>
         <p:spPr>
           <a:xfrm>
-            <a:off x="6053327" y="1783080"/>
-            <a:ext cx="2743200" cy="1362456"/>
+            <a:off x="6126479" y="1874519"/>
+            <a:ext cx="2651760" cy="1316736"/>
           </a:xfrm>
           <a:prstGeom prst="rect">
             <a:avLst/>
@@ -7867,8 +7823,8 @@
         </p:nvSpPr>
         <p:spPr>
           <a:xfrm>
-            <a:off x="6053327" y="3218688"/>
-            <a:ext cx="2743200" cy="1371600"/>
+            <a:off x="6126479" y="3273552"/>
+            <a:ext cx="2651760" cy="822960"/>
           </a:xfrm>
           <a:prstGeom prst="rect">
             <a:avLst/>
@@ -7897,7 +7853,7 @@
                 <a:cs typeface="Google Sans Flex"/>
                 <a:sym typeface="Google Sans Flex"/>
               </a:rPr>
-              <a:t>Old runs stay here. Open one again instead of starting over.</a:t>
+              <a:t>Past runs stay here.</a:t>
             </a:r>
           </a:p>
         </p:txBody>
@@ -8115,7 +8071,7 @@
                 <a:cs typeface="Google Sans Flex"/>
                 <a:sym typeface="Google Sans Flex"/>
               </a:rPr>
-              <a:t>There is no benchmark table on purpose. We did not want a number on this slide that we had not measured.</a:t>
+              <a:t>A chapter-length run finishes. Filming the slides is the slow step.</a:t>
             </a:r>
           </a:p>
           <a:p>
@@ -8137,51 +8093,7 @@
                 <a:cs typeface="Google Sans Flex"/>
                 <a:sym typeface="Google Sans Flex"/>
               </a:rPr>
-              <a:t>Every run does write down how long each step took. That lives with the job, not in a slide we typed.</a:t>
-            </a:r>
-          </a:p>
-          <a:p>
-            <a:pPr algn="l">
-              <a:spcBef>
-                <a:spcPts val="0"/>
-              </a:spcBef>
-              <a:spcAft>
-                <a:spcPts val="800"/>
-              </a:spcAft>
-            </a:pPr>
-            <a:r>
-              <a:rPr sz="1400" b="0" i="0">
-                <a:solidFill>
-                  <a:srgbClr val="1F1F1F"/>
-                </a:solidFill>
-                <a:latin typeface="Google Sans Flex"/>
-                <a:ea typeface="Google Sans Flex"/>
-                <a:cs typeface="Google Sans Flex"/>
-                <a:sym typeface="Google Sans Flex"/>
-              </a:rPr>
-              <a:t>Filming is the slow step. We shoot the movement at the start of a slide and hold the frame, so a long voiceover is not a screenshot every fraction of a second.</a:t>
-            </a:r>
-          </a:p>
-          <a:p>
-            <a:pPr algn="l">
-              <a:spcBef>
-                <a:spcPts val="0"/>
-              </a:spcBef>
-              <a:spcAft>
-                <a:spcPts val="800"/>
-              </a:spcAft>
-            </a:pPr>
-            <a:r>
-              <a:rPr sz="1400" b="0" i="0">
-                <a:solidFill>
-                  <a:srgbClr val="1F1F1F"/>
-                </a:solidFill>
-                <a:latin typeface="Google Sans Flex"/>
-                <a:ea typeface="Google Sans Flex"/>
-                <a:cs typeface="Google Sans Flex"/>
-                <a:sym typeface="Google Sans Flex"/>
-              </a:rPr>
-              <a:t>If Gemini is busy, that step waits and tries again. The run does not stop in the middle and leave a broken file.</a:t>
+              <a:t>We have not published a benchmark table. Each job does record how long its own steps took.</a:t>
             </a:r>
           </a:p>
         </p:txBody>
@@ -8399,7 +8311,7 @@
                 <a:cs typeface="Google Sans Flex"/>
                 <a:sym typeface="Google Sans Flex"/>
               </a:rPr>
-              <a:t>Next we want the Studio to feel more obvious: fewer choices, a clearer next step, and the look of the slides kept in step with the style you picked.</a:t>
+              <a:t>Next: handwritten teaching slides, and Manim-style motion when the chapter has a formula.</a:t>
             </a:r>
           </a:p>
           <a:p>
@@ -8421,51 +8333,7 @@
                 <a:cs typeface="Google Sans Flex"/>
                 <a:sym typeface="Google Sans Flex"/>
               </a:rPr>
-              <a:t>Handwritten teaching templates, separate from the board we have now, so a maths or science idea can look drawn rather than typed.</a:t>
-            </a:r>
-          </a:p>
-          <a:p>
-            <a:pPr algn="l">
-              <a:spcBef>
-                <a:spcPts val="0"/>
-              </a:spcBef>
-              <a:spcAft>
-                <a:spcPts val="800"/>
-              </a:spcAft>
-            </a:pPr>
-            <a:r>
-              <a:rPr sz="1400" b="0" i="0">
-                <a:solidFill>
-                  <a:srgbClr val="1F1F1F"/>
-                </a:solidFill>
-                <a:latin typeface="Google Sans Flex"/>
-                <a:ea typeface="Google Sans Flex"/>
-                <a:cs typeface="Google Sans Flex"/>
-                <a:sym typeface="Google Sans Flex"/>
-              </a:rPr>
-              <a:t>Manim-style motion for formulas. Predefined YouTuber looks, plus a custom one. Better animation models, both the ones we ship and ones a teacher can add.</a:t>
-            </a:r>
-          </a:p>
-          <a:p>
-            <a:pPr algn="l">
-              <a:spcBef>
-                <a:spcPts val="0"/>
-              </a:spcBef>
-              <a:spcAft>
-                <a:spcPts val="800"/>
-              </a:spcAft>
-            </a:pPr>
-            <a:r>
-              <a:rPr sz="1400" b="0" i="0">
-                <a:solidFill>
-                  <a:srgbClr val="1F1F1F"/>
-                </a:solidFill>
-                <a:latin typeface="Google Sans Flex"/>
-                <a:ea typeface="Google Sans Flex"/>
-                <a:cs typeface="Google Sans Flex"/>
-                <a:sym typeface="Google Sans Flex"/>
-              </a:rPr>
-              <a:t>New animation skills you can drop in, the way a style is picked today. A Short cut from the long lesson without doing it by hand.</a:t>
+              <a:t>After that, a few YouTuber looks you can pick, or make your own.</a:t>
             </a:r>
           </a:p>
         </p:txBody>
@@ -8808,7 +8676,7 @@
                 <a:cs typeface="Google Sans Flex"/>
                 <a:sym typeface="Google Sans Flex"/>
               </a:rPr>
-              <a:t>Demo video: 3 to 4 minutes of one real file becoming an MP4. Link still to be pasted.</a:t>
+              <a:t>Demo video: still to record (3 to 4 minutes, one real file).</a:t>
             </a:r>
           </a:p>
           <a:p>
@@ -8831,28 +8699,6 @@
                 <a:sym typeface="Google Sans Flex"/>
               </a:rPr>
               <a:t>Product: https://multimodal-studio-469528918286.us-central1.run.app</a:t>
-            </a:r>
-          </a:p>
-          <a:p>
-            <a:pPr algn="l">
-              <a:spcBef>
-                <a:spcPts val="800"/>
-              </a:spcBef>
-              <a:spcAft>
-                <a:spcPts val="0"/>
-              </a:spcAft>
-            </a:pPr>
-            <a:r>
-              <a:rPr sz="1300" b="0" i="0">
-                <a:solidFill>
-                  <a:srgbClr val="1F1F1F"/>
-                </a:solidFill>
-                <a:latin typeface="Google Sans Flex"/>
-                <a:ea typeface="Google Sans Flex"/>
-                <a:cs typeface="Google Sans Flex"/>
-                <a:sym typeface="Google Sans Flex"/>
-              </a:rPr>
-              <a:t>That link opens in Studio. There is no login.</a:t>
             </a:r>
           </a:p>
         </p:txBody>
@@ -9503,7 +9349,7 @@
                 <a:cs typeface="Google Sans Flex"/>
                 <a:sym typeface="Google Sans Flex"/>
               </a:rPr>
-              <a:t>Anil Kumar leads the team. M Sai Teja builds with him. We kept turning chapters into slides and then sitting down to record.</a:t>
+              <a:t>M Sai Teja leads and built this.</a:t>
             </a:r>
           </a:p>
           <a:p>
@@ -9525,7 +9371,7 @@
                 <a:cs typeface="Google Sans Flex"/>
                 <a:sym typeface="Google Sans Flex"/>
               </a:rPr>
-              <a:t>Multimodal Studio is for a teacher, a tutor, or a student who wants the idea to stick. Drop the PDF or the notes, say the age, and you get a video with a voice already on it.</a:t>
+              <a:t>You drop a chapter or a set of notes. You get a short video a class can replay. Gemini writes the slides. Gemini 3.8 Live speaks them.</a:t>
             </a:r>
           </a:p>
           <a:p>
@@ -9547,7 +9393,7 @@
                 <a:cs typeface="Google Sans Flex"/>
                 <a:sym typeface="Google Sans Flex"/>
               </a:rPr>
-              <a:t>The fun is in the timing. The highlight moves when the sentence does, so it feels like someone explaining, not a page being read out. Gemini writes it. Gemini 3.8 Live speaks it. The review link opens with no login.</a:t>
+              <a:t>The highlight moves with the sentence, so it feels like someone explaining, not a page being read out.</a:t>
             </a:r>
           </a:p>
         </p:txBody>
@@ -9897,7 +9743,7 @@
                 <a:cs typeface="Google Sans Flex SemiBold"/>
                 <a:sym typeface="Google Sans Flex SemiBold"/>
               </a:rPr>
-              <a:t>How it is different</a:t>
+              <a:t>Different from what exists</a:t>
             </a:r>
           </a:p>
           <a:p>
@@ -9919,7 +9765,7 @@
                 <a:cs typeface="Google Sans Flex"/>
                 <a:sym typeface="Google Sans Flex"/>
               </a:rPr>
-              <a:t>Slide tools stop at the deck. Read-aloud tools stay in one tone and ignore the picture. A teacher was still doing the joining. This goes from the file to a video a class can replay.</a:t>
+              <a:t>Slide tools stop at the deck. Read-aloud tools ignore the picture. Neither gives a class a video.</a:t>
             </a:r>
           </a:p>
           <a:p>
@@ -9941,7 +9787,7 @@
                 <a:cs typeface="Google Sans Flex SemiBold"/>
                 <a:sym typeface="Google Sans Flex SemiBold"/>
               </a:rPr>
-              <a:t>How it solves it</a:t>
+              <a:t>How it solves the problem</a:t>
             </a:r>
           </a:p>
           <a:p>
@@ -9963,7 +9809,7 @@
                 <a:cs typeface="Google Sans Flex"/>
                 <a:sym typeface="Google Sans Flex"/>
               </a:rPr>
-              <a:t>The slow part was the middle: slides a student can follow, a voice with some life in it, and a highlight that walks with the sentence. That middle is the product.</a:t>
+              <a:t>One file goes in. A video comes out. The teacher does not record, and does not line the voice up by hand.</a:t>
             </a:r>
           </a:p>
           <a:p>
@@ -9985,7 +9831,7 @@
                 <a:cs typeface="Google Sans Flex SemiBold"/>
                 <a:sym typeface="Google Sans Flex SemiBold"/>
               </a:rPr>
-              <a:t>What we would defend</a:t>
+              <a:t>USP</a:t>
             </a:r>
           </a:p>
           <a:p>
@@ -10007,7 +9853,7 @@
                 <a:cs typeface="Google Sans Flex"/>
                 <a:sym typeface="Google Sans Flex"/>
               </a:rPr>
-              <a:t>One Gemini key. A voice that does not sound like a station announcement. A link anyone on the review team can open.</a:t>
+              <a:t>The voice and the highlight stay in time. That is the part a normal deck and a normal voiceover both miss.</a:t>
             </a:r>
           </a:p>
         </p:txBody>
@@ -10225,7 +10071,7 @@
                 <a:cs typeface="Google Sans Flex"/>
                 <a:sym typeface="Google Sans Flex"/>
               </a:rPr>
-              <a:t>A teacher can turn one chapter into a YouTube lesson, a Short, or a Reel. The length follows the format.</a:t>
+              <a:t>Drop a PDF. Get a video for YouTube or a Short.</a:t>
             </a:r>
           </a:p>
           <a:p>
@@ -10247,7 +10093,7 @@
                 <a:cs typeface="Google Sans Flex"/>
                 <a:sym typeface="Google Sans Flex"/>
               </a:rPr>
-              <a:t>Age and how much the viewer already knows change the wording. A class of 16-year-olds does not get the same script as a beginner.</a:t>
+              <a:t>Say the age. The wording changes for that class.</a:t>
             </a:r>
           </a:p>
           <a:p>
@@ -10269,73 +10115,7 @@
                 <a:cs typeface="Google Sans Flex"/>
                 <a:sym typeface="Google Sans Flex"/>
               </a:rPr>
-              <a:t>Gemini 3.8 Live speaks it. Kore is the demo voice. You can preview before you run.</a:t>
-            </a:r>
-          </a:p>
-          <a:p>
-            <a:pPr algn="l">
-              <a:spcBef>
-                <a:spcPts val="0"/>
-              </a:spcBef>
-              <a:spcAft>
-                <a:spcPts val="800"/>
-              </a:spcAft>
-            </a:pPr>
-            <a:r>
-              <a:rPr sz="1300" b="0" i="0">
-                <a:solidFill>
-                  <a:srgbClr val="1F1F1F"/>
-                </a:solidFill>
-                <a:latin typeface="Google Sans Flex"/>
-                <a:ea typeface="Google Sans Flex"/>
-                <a:cs typeface="Google Sans Flex"/>
-                <a:sym typeface="Google Sans Flex"/>
-              </a:rPr>
-              <a:t>A long PDF can be split into topics, then one video or a few, so a unit does not have to be one 40-minute file.</a:t>
-            </a:r>
-          </a:p>
-          <a:p>
-            <a:pPr algn="l">
-              <a:spcBef>
-                <a:spcPts val="0"/>
-              </a:spcBef>
-              <a:spcAft>
-                <a:spcPts val="800"/>
-              </a:spcAft>
-            </a:pPr>
-            <a:r>
-              <a:rPr sz="1300" b="0" i="0">
-                <a:solidFill>
-                  <a:srgbClr val="1F1F1F"/>
-                </a:solidFill>
-                <a:latin typeface="Google Sans Flex"/>
-                <a:ea typeface="Google Sans Flex"/>
-                <a:cs typeface="Google Sans Flex"/>
-                <a:sym typeface="Google Sans Flex"/>
-              </a:rPr>
-              <a:t>It flags a slide that repeats the one before it, and the on-screen highlight stays with the voice.</a:t>
-            </a:r>
-          </a:p>
-          <a:p>
-            <a:pPr algn="l">
-              <a:spcBef>
-                <a:spcPts val="0"/>
-              </a:spcBef>
-              <a:spcAft>
-                <a:spcPts val="800"/>
-              </a:spcAft>
-            </a:pPr>
-            <a:r>
-              <a:rPr sz="1300" b="0" i="0">
-                <a:solidFill>
-                  <a:srgbClr val="1F1F1F"/>
-                </a:solidFill>
-                <a:latin typeface="Google Sans Flex"/>
-                <a:ea typeface="Google Sans Flex"/>
-                <a:cs typeface="Google Sans Flex"/>
-                <a:sym typeface="Google Sans Flex"/>
-              </a:rPr>
-              <a:t>Title, description, and thumbnail come out with the file.</a:t>
+              <a:t>Gemini 3.8 Live speaks it, and the highlight follows the voice.</a:t>
             </a:r>
           </a:p>
         </p:txBody>
@@ -10950,29 +10730,7 @@
                 <a:cs typeface="Google Sans Flex"/>
                 <a:sym typeface="Google Sans Flex"/>
               </a:rPr>
-              <a:t>Same path if you uploaded the file, or if the overnight job picked a paper.</a:t>
-            </a:r>
-          </a:p>
-          <a:p>
-            <a:pPr algn="l">
-              <a:spcBef>
-                <a:spcPts val="0"/>
-              </a:spcBef>
-              <a:spcAft>
-                <a:spcPts val="800"/>
-              </a:spcAft>
-            </a:pPr>
-            <a:r>
-              <a:rPr sz="1400" b="0" i="0">
-                <a:solidFill>
-                  <a:srgbClr val="1F1F1F"/>
-                </a:solidFill>
-                <a:latin typeface="Google Sans Flex"/>
-                <a:ea typeface="Google Sans Flex"/>
-                <a:cs typeface="Google Sans Flex"/>
-                <a:sym typeface="Google Sans Flex"/>
-              </a:rPr>
-              <a:t>Speaking is Gemini 3.8 Live, so the voice has pauses and a bit of warmth. It is not a flat read-out.</a:t>
+              <a:t>Upload a chapter, or let the queue pick a paper. Then one path to the video.</a:t>
             </a:r>
           </a:p>
         </p:txBody>
@@ -11205,7 +10963,7 @@
               </a:spcAft>
             </a:pPr>
             <a:r>
-              <a:rPr sz="1300" b="0" i="0">
+              <a:rPr sz="1400" b="0" i="0">
                 <a:solidFill>
                   <a:srgbClr val="1F1F1F"/>
                 </a:solidFill>
@@ -11214,7 +10972,7 @@
                 <a:cs typeface="Google Sans Flex SemiBold"/>
                 <a:sym typeface="Google Sans Flex SemiBold"/>
               </a:rPr>
-              <a:t>What you actually see</a:t>
+              <a:t>The Studio page</a:t>
             </a:r>
           </a:p>
           <a:p>
@@ -11236,73 +10994,7 @@
                 <a:cs typeface="Google Sans Flex"/>
                 <a:sym typeface="Google Sans Flex"/>
               </a:rPr>
-              <a:t>The file goes on the left.</a:t>
-            </a:r>
-          </a:p>
-          <a:p>
-            <a:pPr algn="l">
-              <a:spcBef>
-                <a:spcPts val="0"/>
-              </a:spcBef>
-              <a:spcAft>
-                <a:spcPts val="800"/>
-              </a:spcAft>
-            </a:pPr>
-            <a:r>
-              <a:rPr sz="1300" b="0" i="0">
-                <a:solidFill>
-                  <a:srgbClr val="1F1F1F"/>
-                </a:solidFill>
-                <a:latin typeface="Google Sans Flex"/>
-                <a:ea typeface="Google Sans Flex"/>
-                <a:cs typeface="Google Sans Flex"/>
-                <a:sym typeface="Google Sans Flex"/>
-              </a:rPr>
-              <a:t>Format and voice are next to it.</a:t>
-            </a:r>
-          </a:p>
-          <a:p>
-            <a:pPr algn="l">
-              <a:spcBef>
-                <a:spcPts val="0"/>
-              </a:spcBef>
-              <a:spcAft>
-                <a:spcPts val="800"/>
-              </a:spcAft>
-            </a:pPr>
-            <a:r>
-              <a:rPr sz="1300" b="0" i="0">
-                <a:solidFill>
-                  <a:srgbClr val="1F1F1F"/>
-                </a:solidFill>
-                <a:latin typeface="Google Sans Flex"/>
-                <a:ea typeface="Google Sans Flex"/>
-                <a:cs typeface="Google Sans Flex"/>
-                <a:sym typeface="Google Sans Flex"/>
-              </a:rPr>
-              <a:t>You press run and wait on the same page.</a:t>
-            </a:r>
-          </a:p>
-          <a:p>
-            <a:pPr algn="l">
-              <a:spcBef>
-                <a:spcPts val="0"/>
-              </a:spcBef>
-              <a:spcAft>
-                <a:spcPts val="800"/>
-              </a:spcAft>
-            </a:pPr>
-            <a:r>
-              <a:rPr sz="1300" b="0" i="0">
-                <a:solidFill>
-                  <a:srgbClr val="1F1F1F"/>
-                </a:solidFill>
-                <a:latin typeface="Google Sans Flex"/>
-                <a:ea typeface="Google Sans Flex"/>
-                <a:cs typeface="Google Sans Flex"/>
-                <a:sym typeface="Google Sans Flex"/>
-              </a:rPr>
-              <a:t>The MP4 plays there when it is done. History keeps the old ones.</a:t>
+              <a:t>File on the left. Format and voice beside it. Run, then play the video on the same page.</a:t>
             </a:r>
           </a:p>
         </p:txBody>
@@ -11520,7 +11212,7 @@
                 <a:cs typeface="Google Sans Flex"/>
                 <a:sym typeface="Google Sans Flex"/>
               </a:rPr>
-              <a:t>Browser  →  our Python app on Cloud Run  →  Gemini  →  an MP4</a:t>
+              <a:t>Studio page  →  Cloud Run  →  Gemini  →  MP4</a:t>
             </a:r>
           </a:p>
           <a:p>
@@ -11542,7 +11234,7 @@
                 <a:cs typeface="Google Sans Flex"/>
                 <a:sym typeface="Google Sans Flex"/>
               </a:rPr>
-              <a:t>The page is the Studio you saw. The server asks Gemini 3.8 Flash (or Argon) to read the file and write the slides. Gemini 3.8 Live speaks them. A headless Chrome photographs the slides. FFmpeg puts the sound on.</a:t>
+              <a:t>Gemini 3.8 Flash reads the file and writes the slides. Gemini 3.8 Live speaks them. Chrome films the frames. FFmpeg joins the sound.</a:t>
             </a:r>
           </a:p>
           <a:p>
@@ -11564,7 +11256,7 @@
                 <a:cs typeface="Google Sans Flex"/>
                 <a:sym typeface="Google Sans Flex"/>
               </a:rPr>
-              <a:t>Each job is saved on the machine and copied to Firestore. Firebase Hosting only serves this pitch. The app itself is Cloud Run.</a:t>
+              <a:t>Each job is copied to Firestore. This pitch page is on Firebase Hosting.</a:t>
             </a:r>
           </a:p>
         </p:txBody>
@@ -11782,7 +11474,7 @@
                 <a:cs typeface="Google Sans Flex"/>
                 <a:sym typeface="Google Sans Flex"/>
               </a:rPr>
-              <a:t>Writing, and reading pages: Gemini 3.8 Flash. Gemini 4 Argon when the source is dense and we want it to think harder.</a:t>
+              <a:t>Gemini 3.8 Flash writes the slides. Gemini 4 Argon is there when the chapter is dense.</a:t>
             </a:r>
           </a:p>
           <a:p>
@@ -11804,7 +11496,7 @@
                 <a:cs typeface="Google Sans Flex"/>
                 <a:sym typeface="Google Sans Flex"/>
               </a:rPr>
-              <a:t>Voice: Gemini 3.8 Live. Same family as the in-app assistant. We stopped using a separate flat text-to-speech voice.</a:t>
+              <a:t>Gemini 3.8 Live is the voice.</a:t>
             </a:r>
           </a:p>
           <a:p>
@@ -11826,51 +11518,7 @@
                 <a:cs typeface="Google Sans Flex"/>
                 <a:sym typeface="Google Sans Flex"/>
               </a:rPr>
-              <a:t>Thumbnail only: Nano Banana. It does not draw the slides.</a:t>
-            </a:r>
-          </a:p>
-          <a:p>
-            <a:pPr algn="l">
-              <a:spcBef>
-                <a:spcPts val="0"/>
-              </a:spcBef>
-              <a:spcAft>
-                <a:spcPts val="800"/>
-              </a:spcAft>
-            </a:pPr>
-            <a:r>
-              <a:rPr sz="1400" b="0" i="0">
-                <a:solidFill>
-                  <a:srgbClr val="1F1F1F"/>
-                </a:solidFill>
-                <a:latin typeface="Google Sans Flex"/>
-                <a:ea typeface="Google Sans Flex"/>
-                <a:cs typeface="Google Sans Flex"/>
-                <a:sym typeface="Google Sans Flex"/>
-              </a:rPr>
-              <a:t>App: Python, FastAPI, HTML slides, headless Chrome, FFmpeg.</a:t>
-            </a:r>
-          </a:p>
-          <a:p>
-            <a:pPr algn="l">
-              <a:spcBef>
-                <a:spcPts val="0"/>
-              </a:spcBef>
-              <a:spcAft>
-                <a:spcPts val="800"/>
-              </a:spcAft>
-            </a:pPr>
-            <a:r>
-              <a:rPr sz="1400" b="0" i="0">
-                <a:solidFill>
-                  <a:srgbClr val="1F1F1F"/>
-                </a:solidFill>
-                <a:latin typeface="Google Sans Flex"/>
-                <a:ea typeface="Google Sans Flex"/>
-                <a:cs typeface="Google Sans Flex"/>
-                <a:sym typeface="Google Sans Flex"/>
-              </a:rPr>
-              <a:t>Hosting: Cloud Run. This page: Firebase Hosting. Job copy: Firestore.</a:t>
+              <a:t>Cloud Run hosts the app. Firestore keeps each job. Firebase Hosting serves this pitch.</a:t>
             </a:r>
           </a:p>
         </p:txBody>

</xml_diff>